<commit_message>
docs(report): fill in the v0.2.0 release verification and fit five pages
The verification line now carries the real tag commit (17b1eea9939c) and the
release CI run that produced it, so no [확인 필요: marker survives.

Word puts the regenerated body at six pages, one over the rule, so the prose
is tightened until it measures five again: 13 pages total, the same as the
0.1.1 submission. Editing this text without re-measuring is how it silently
goes over.

The video deck slides still claimed 35 tests and 0.1.0.
</commit_message>
<xml_diff>
--- a/docs/competition/submission/Reqover_3min_video_deck.pptx
+++ b/docs/competition/submission/Reqover_3min_video_deck.pptx
@@ -3192,7 +3192,7 @@
                 <a:ea typeface="Apple SD Gothic Neo"/>
                 <a:cs typeface="Apple SD Gothic Neo"/>
               </a:rPr>
-              <a:t>35</a:t>
+              <a:t>121</a:t>
             </a:r>
           </a:p>
         </p:txBody>
@@ -3639,7 +3639,7 @@
                 <a:cs typeface="Apple SD Gothic Neo"/>
               </a:rPr>
               <a:t>REQOVER
-0.1.0</a:t>
+0.2.0</a:t>
             </a:r>
           </a:p>
         </p:txBody>

</xml_diff>